<commit_message>
sync docs/ from travplan@93fc73d
</commit_message>
<xml_diff>
--- a/slides/research-mimic/research-mimic.pptx
+++ b/slides/research-mimic/research-mimic.pptx
@@ -43593,7 +43593,7 @@
         </p:nvGraphicFramePr>
         <p:xfrm>
           <a:off x="609600" y="1244600"/>
-          <a:ext cx="10966450" cy="3860400"/>
+          <a:ext cx="10966450" cy="3542424"/>
         </p:xfrm>
         <a:graphic>
           <a:graphicData uri="http://schemas.openxmlformats.org/drawingml/2006/table">
@@ -44813,127 +44813,6 @@
                   <a:tcPr marL="63500" marR="63500" marT="12700" marB="12700">
                     <a:solidFill>
                       <a:srgbClr val="FFFDF8"/>
-                    </a:solidFill>
-                  </a:tcPr>
-                </a:tc>
-              </a:tr>
-              <a:tr h="317976">
-                <a:tc>
-                  <a:txBody>
-                    <a:bodyPr wrap="square"/>
-                    <a:lstStyle/>
-                    <a:p>
-                      <a:r>
-                        <a:rPr sz="800" b="0" i="0">
-                          <a:solidFill>
-                            <a:srgbClr val="16213A"/>
-                          </a:solidFill>
-                          <a:latin typeface="Arial"/>
-                          <a:ea typeface="Malgun Gothic"/>
-                          <a:cs typeface="Malgun Gothic"/>
-                        </a:rPr>
-                        <a:t>지형·접촉</a:t>
-                      </a:r>
-                    </a:p>
-                  </a:txBody>
-                  <a:tcPr marL="63500" marR="63500" marT="12700" marB="12700">
-                    <a:solidFill>
-                      <a:srgbClr val="F3F0E8"/>
-                    </a:solidFill>
-                  </a:tcPr>
-                </a:tc>
-                <a:tc>
-                  <a:txBody>
-                    <a:bodyPr wrap="square"/>
-                    <a:lstStyle/>
-                    <a:p>
-                      <a:r>
-                        <a:rPr sz="800" b="0" i="0">
-                          <a:solidFill>
-                            <a:srgbClr val="16213A"/>
-                          </a:solidFill>
-                          <a:latin typeface="Arial"/>
-                          <a:ea typeface="Malgun Gothic"/>
-                          <a:cs typeface="Malgun Gothic"/>
-                        </a:rPr>
-                        <a:t>NEXUS(</a:t>
-                      </a:r>
-                      <a:r>
-                        <a:rPr sz="800" b="0" i="0">
-                          <a:solidFill>
-                            <a:srgbClr val="1D4ED8"/>
-                          </a:solidFill>
-                          <a:latin typeface="Arial"/>
-                          <a:ea typeface="Malgun Gothic"/>
-                          <a:cs typeface="Malgun Gothic"/>
-                          <a:hlinkClick r:id="rId13"/>
-                        </a:rPr>
-                        <a:t>arXiv:2609.39000</a:t>
-                      </a:r>
-                      <a:r>
-                        <a:rPr sz="800" b="0" i="0">
-                          <a:solidFill>
-                            <a:srgbClr val="16213A"/>
-                          </a:solidFill>
-                          <a:latin typeface="Arial"/>
-                          <a:ea typeface="Malgun Gothic"/>
-                          <a:cs typeface="Malgun Gothic"/>
-                        </a:rPr>
-                        <a:t>)</a:t>
-                      </a:r>
-                    </a:p>
-                  </a:txBody>
-                  <a:tcPr marL="63500" marR="63500" marT="12700" marB="12700">
-                    <a:solidFill>
-                      <a:srgbClr val="F3F0E8"/>
-                    </a:solidFill>
-                  </a:tcPr>
-                </a:tc>
-                <a:tc>
-                  <a:txBody>
-                    <a:bodyPr wrap="square"/>
-                    <a:lstStyle/>
-                    <a:p>
-                      <a:r>
-                        <a:rPr sz="800" b="0" i="0">
-                          <a:solidFill>
-                            <a:srgbClr val="16213A"/>
-                          </a:solidFill>
-                          <a:latin typeface="Arial"/>
-                          <a:ea typeface="Malgun Gothic"/>
-                          <a:cs typeface="Malgun Gothic"/>
-                        </a:rPr>
-                        <a:t>평지 동작을 지형 짝 데이터(약 1,000시간)로 바꿔, 운영자는 평지에 서 있고 로봇은 계단에 맞춤</a:t>
-                      </a:r>
-                    </a:p>
-                  </a:txBody>
-                  <a:tcPr marL="63500" marR="63500" marT="12700" marB="12700">
-                    <a:solidFill>
-                      <a:srgbClr val="F3F0E8"/>
-                    </a:solidFill>
-                  </a:tcPr>
-                </a:tc>
-                <a:tc>
-                  <a:txBody>
-                    <a:bodyPr wrap="square"/>
-                    <a:lstStyle/>
-                    <a:p>
-                      <a:r>
-                        <a:rPr sz="800" b="0" i="0">
-                          <a:solidFill>
-                            <a:srgbClr val="16213A"/>
-                          </a:solidFill>
-                          <a:latin typeface="Arial"/>
-                          <a:ea typeface="Malgun Gothic"/>
-                          <a:cs typeface="Malgun Gothic"/>
-                        </a:rPr>
-                        <a:t>보지 않은 클립 8,300회 성공 91.07 %(시각 없이 87.77 %)</a:t>
-                      </a:r>
-                    </a:p>
-                  </a:txBody>
-                  <a:tcPr marL="63500" marR="63500" marT="12700" marB="12700">
-                    <a:solidFill>
-                      <a:srgbClr val="F3F0E8"/>
                     </a:solidFill>
                   </a:tcPr>
                 </a:tc>
@@ -45100,7 +44979,7 @@
         </p:nvGraphicFramePr>
         <p:xfrm>
           <a:off x="609600" y="1244600"/>
-          <a:ext cx="10966450" cy="1786968"/>
+          <a:ext cx="10966450" cy="2225832"/>
         </p:xfrm>
         <a:graphic>
           <a:graphicData uri="http://schemas.openxmlformats.org/drawingml/2006/table">
@@ -45212,7 +45091,7 @@
                   </a:tcPr>
                 </a:tc>
               </a:tr>
-              <a:tr h="317976">
+              <a:tr h="438864">
                 <a:tc>
                   <a:txBody>
                     <a:bodyPr wrap="square"/>
@@ -45251,7 +45130,7 @@
                           <a:ea typeface="Malgun Gothic"/>
                           <a:cs typeface="Malgun Gothic"/>
                         </a:rPr>
-                        <a:t>P-BFM(</a:t>
+                        <a:t>NEXUS(</a:t>
                       </a:r>
                       <a:r>
                         <a:rPr sz="800" b="0" i="0">
@@ -45263,7 +45142,7 @@
                           <a:cs typeface="Malgun Gothic"/>
                           <a:hlinkClick r:id="rId3"/>
                         </a:rPr>
-                        <a:t>arXiv:2610.15833</a:t>
+                        <a:t>arXiv:2609.39000</a:t>
                       </a:r>
                       <a:r>
                         <a:rPr sz="800" b="0" i="0">
@@ -45297,7 +45176,7 @@
                           <a:ea typeface="Malgun Gothic"/>
                           <a:cs typeface="Malgun Gothic"/>
                         </a:rPr>
-                        <a:t>)</a:t>
+                        <a:t> CC BY-NC 4.0, Planner B.16.6)</a:t>
                       </a:r>
                     </a:p>
                   </a:txBody>
@@ -45321,7 +45200,7 @@
                           <a:ea typeface="Malgun Gothic"/>
                           <a:cs typeface="Malgun Gothic"/>
                         </a:rPr>
-                        <a:t>비지도 RL 행동 기반 모델(BFM-Zero 갈래)에 지형 인식을 더함</a:t>
+                        <a:t>평지 동작을 지형 위 동작으로 자동 변환한 짝 데이터(적응 변형 포함 약 1,000시간)로, 운영자는 평지에 서 있고 로봇은 깊이 영상을 보고 계단·경사에 맞춤</a:t>
                       </a:r>
                     </a:p>
                   </a:txBody>
@@ -45345,7 +45224,7 @@
                           <a:ea typeface="Malgun Gothic"/>
                           <a:cs typeface="Malgun Gothic"/>
                         </a:rPr>
-                        <a:t>지형 7종 × 10레벨, 보지 않은 동작 994개에서 관절 오차 0.13 rad(같은 연구실 UFO 0.16 rad), 밀기 외란 뒤 추종 회복률 61.4 %(UFO 16.6 %, 표 1)</a:t>
+                        <a:t>어려운 지형 성공 51.9 %(지형을 안 보는 SONIC v1.1 31.76 %). 보지 않은 이동 클립 415개 × 8,300회 시행에서 91.07 %(시각 없이 87.77 %, 교사–학생 없이 90.96 %)</a:t>
                       </a:r>
                     </a:p>
                   </a:txBody>
@@ -45371,7 +45250,7 @@
                           <a:ea typeface="Malgun Gothic"/>
                           <a:cs typeface="Malgun Gothic"/>
                         </a:rPr>
-                        <a:t>순응·안전</a:t>
+                        <a:t>지형·접촉</a:t>
                       </a:r>
                     </a:p>
                   </a:txBody>
@@ -45395,7 +45274,7 @@
                           <a:ea typeface="Malgun Gothic"/>
                           <a:cs typeface="Malgun Gothic"/>
                         </a:rPr>
-                        <a:t>GentleHumanoid(</a:t>
+                        <a:t>P-BFM(</a:t>
                       </a:r>
                       <a:r>
                         <a:rPr sz="800" b="0" i="0">
@@ -45407,18 +45286,41 @@
                           <a:cs typeface="Malgun Gothic"/>
                           <a:hlinkClick r:id="rId5"/>
                         </a:rPr>
-                        <a:t>arXiv:2511.04679</a:t>
-                      </a:r>
-                      <a:r>
-                        <a:rPr sz="800" b="0" i="0">
-                          <a:solidFill>
-                            <a:srgbClr val="16213A"/>
-                          </a:solidFill>
-                          <a:latin typeface="Arial"/>
-                          <a:ea typeface="Malgun Gothic"/>
-                          <a:cs typeface="Malgun Gothic"/>
-                        </a:rPr>
-                        <a:t>, Stanford)</a:t>
+                        <a:t>arXiv:2610.15833</a:t>
+                      </a:r>
+                      <a:r>
+                        <a:rPr sz="800" b="0" i="0">
+                          <a:solidFill>
+                            <a:srgbClr val="16213A"/>
+                          </a:solidFill>
+                          <a:latin typeface="Arial"/>
+                          <a:ea typeface="Malgun Gothic"/>
+                          <a:cs typeface="Malgun Gothic"/>
+                        </a:rPr>
+                        <a:t>, </a:t>
+                      </a:r>
+                      <a:r>
+                        <a:rPr sz="800" b="0" i="0">
+                          <a:solidFill>
+                            <a:srgbClr val="1D4ED8"/>
+                          </a:solidFill>
+                          <a:latin typeface="Arial"/>
+                          <a:ea typeface="Malgun Gothic"/>
+                          <a:cs typeface="Malgun Gothic"/>
+                          <a:hlinkClick r:id="rId6"/>
+                        </a:rPr>
+                        <a:t>코드</a:t>
+                      </a:r>
+                      <a:r>
+                        <a:rPr sz="800" b="0" i="0">
+                          <a:solidFill>
+                            <a:srgbClr val="16213A"/>
+                          </a:solidFill>
+                          <a:latin typeface="Arial"/>
+                          <a:ea typeface="Malgun Gothic"/>
+                          <a:cs typeface="Malgun Gothic"/>
+                        </a:rPr>
+                        <a:t>)</a:t>
                       </a:r>
                     </a:p>
                   </a:txBody>
@@ -45442,7 +45344,7 @@
                           <a:ea typeface="Malgun Gothic"/>
                           <a:cs typeface="Malgun Gothic"/>
                         </a:rPr>
-                        <a:t>힘 상한(5–15 N)을 표집해 정책 입력으로 주는 상체 순응 추종. 범위는 ISO/TS 15066을 근거로 정함</a:t>
+                        <a:t>비지도 RL 행동 기반 모델(BFM-Zero 갈래)에 지형 인식을 더함</a:t>
                       </a:r>
                     </a:p>
                   </a:txBody>
@@ -45466,7 +45368,7 @@
                           <a:ea typeface="Malgun Gothic"/>
                           <a:cs typeface="Malgun Gothic"/>
                         </a:rPr>
-                        <a:t>실물 G1 손목을 밀어 팔을 옮기는 데 든 최대 힘이 설정 10 N 안팎(강한 외력으로 학습한 기준선 51.14 N, 일반 RL 24.59 N)</a:t>
+                        <a:t>지형 7종 × 10레벨, 보지 않은 동작 994개에서 관절 오차 0.13 rad(같은 연구실 UFO 0.16 rad), 밀기 외란 뒤 추종 회복률 61.4 %(UFO 16.6 %, 표 1)</a:t>
                       </a:r>
                     </a:p>
                   </a:txBody>
@@ -45516,7 +45418,7 @@
                           <a:ea typeface="Malgun Gothic"/>
                           <a:cs typeface="Malgun Gothic"/>
                         </a:rPr>
-                        <a:t>ConstrainedMimic(</a:t>
+                        <a:t>GentleHumanoid(</a:t>
                       </a:r>
                       <a:r>
                         <a:rPr sz="800" b="0" i="0">
@@ -45526,43 +45428,20 @@
                           <a:latin typeface="Arial"/>
                           <a:ea typeface="Malgun Gothic"/>
                           <a:cs typeface="Malgun Gothic"/>
-                          <a:hlinkClick r:id="rId6"/>
-                        </a:rPr>
-                        <a:t>arXiv:2606.00374</a:t>
-                      </a:r>
-                      <a:r>
-                        <a:rPr sz="800" b="0" i="0">
-                          <a:solidFill>
-                            <a:srgbClr val="16213A"/>
-                          </a:solidFill>
-                          <a:latin typeface="Arial"/>
-                          <a:ea typeface="Malgun Gothic"/>
-                          <a:cs typeface="Malgun Gothic"/>
-                        </a:rPr>
-                        <a:t>, CoRL 2026), CoFiT(</a:t>
-                      </a:r>
-                      <a:r>
-                        <a:rPr sz="800" b="0" i="0">
-                          <a:solidFill>
-                            <a:srgbClr val="1D4ED8"/>
-                          </a:solidFill>
-                          <a:latin typeface="Arial"/>
-                          <a:ea typeface="Malgun Gothic"/>
-                          <a:cs typeface="Malgun Gothic"/>
                           <a:hlinkClick r:id="rId7"/>
                         </a:rPr>
-                        <a:t>arXiv:2610.02341</a:t>
-                      </a:r>
-                      <a:r>
-                        <a:rPr sz="800" b="0" i="0">
-                          <a:solidFill>
-                            <a:srgbClr val="16213A"/>
-                          </a:solidFill>
-                          <a:latin typeface="Arial"/>
-                          <a:ea typeface="Malgun Gothic"/>
-                          <a:cs typeface="Malgun Gothic"/>
-                        </a:rPr>
-                        <a:t>)</a:t>
+                        <a:t>arXiv:2511.04679</a:t>
+                      </a:r>
+                      <a:r>
+                        <a:rPr sz="800" b="0" i="0">
+                          <a:solidFill>
+                            <a:srgbClr val="16213A"/>
+                          </a:solidFill>
+                          <a:latin typeface="Arial"/>
+                          <a:ea typeface="Malgun Gothic"/>
+                          <a:cs typeface="Malgun Gothic"/>
+                        </a:rPr>
+                        <a:t>, Stanford)</a:t>
                       </a:r>
                     </a:p>
                   </a:txBody>
@@ -45586,7 +45465,7 @@
                           <a:ea typeface="Malgun Gothic"/>
                           <a:cs typeface="Malgun Gothic"/>
                         </a:rPr>
-                        <a:t>추종기 위 1 kHz 넘는 OSC(operational space control) + CBF(control barrier function) 제약, 필터를 아는 미세 조정</a:t>
+                        <a:t>힘 상한(5–15 N)을 표집해 정책 입력으로 주는 상체 순응 추종. 범위는 ISO/TS 15066을 근거로 정함</a:t>
                       </a:r>
                     </a:p>
                   </a:txBody>
@@ -45610,7 +45489,7 @@
                           <a:ea typeface="Malgun Gothic"/>
                           <a:cs typeface="Malgun Gothic"/>
                         </a:rPr>
-                        <a:t>CoFiT: 필터만 붙인 경우 대비 제약 위반 시간 TWIST2 −91 %, SONIC −21 %(실물 TWIST2 −83 %)</a:t>
+                        <a:t>실물 G1 손목을 밀어 팔을 옮기는 데 든 최대 힘이 설정 10 N 안팎(강한 외력으로 학습한 기준선 51.14 N, 일반 RL 24.59 N)</a:t>
                       </a:r>
                     </a:p>
                   </a:txBody>
@@ -45660,7 +45539,7 @@
                           <a:ea typeface="Malgun Gothic"/>
                           <a:cs typeface="Malgun Gothic"/>
                         </a:rPr>
-                        <a:t>C-GMT(</a:t>
+                        <a:t>ConstrainedMimic(</a:t>
                       </a:r>
                       <a:r>
                         <a:rPr sz="800" b="0" i="0">
@@ -45672,18 +45551,41 @@
                           <a:cs typeface="Malgun Gothic"/>
                           <a:hlinkClick r:id="rId8"/>
                         </a:rPr>
-                        <a:t>arXiv:2610.22119</a:t>
-                      </a:r>
-                      <a:r>
-                        <a:rPr sz="800" b="0" i="0">
-                          <a:solidFill>
-                            <a:srgbClr val="16213A"/>
-                          </a:solidFill>
-                          <a:latin typeface="Arial"/>
-                          <a:ea typeface="Malgun Gothic"/>
-                          <a:cs typeface="Malgun Gothic"/>
-                        </a:rPr>
-                        <a:t>, MIT)</a:t>
+                        <a:t>arXiv:2606.00374</a:t>
+                      </a:r>
+                      <a:r>
+                        <a:rPr sz="800" b="0" i="0">
+                          <a:solidFill>
+                            <a:srgbClr val="16213A"/>
+                          </a:solidFill>
+                          <a:latin typeface="Arial"/>
+                          <a:ea typeface="Malgun Gothic"/>
+                          <a:cs typeface="Malgun Gothic"/>
+                        </a:rPr>
+                        <a:t>, CoRL 2026), CoFiT(</a:t>
+                      </a:r>
+                      <a:r>
+                        <a:rPr sz="800" b="0" i="0">
+                          <a:solidFill>
+                            <a:srgbClr val="1D4ED8"/>
+                          </a:solidFill>
+                          <a:latin typeface="Arial"/>
+                          <a:ea typeface="Malgun Gothic"/>
+                          <a:cs typeface="Malgun Gothic"/>
+                          <a:hlinkClick r:id="rId9"/>
+                        </a:rPr>
+                        <a:t>arXiv:2610.02341</a:t>
+                      </a:r>
+                      <a:r>
+                        <a:rPr sz="800" b="0" i="0">
+                          <a:solidFill>
+                            <a:srgbClr val="16213A"/>
+                          </a:solidFill>
+                          <a:latin typeface="Arial"/>
+                          <a:ea typeface="Malgun Gothic"/>
+                          <a:cs typeface="Malgun Gothic"/>
+                        </a:rPr>
+                        <a:t>)</a:t>
                       </a:r>
                     </a:p>
                   </a:txBody>
@@ -45707,7 +45609,7 @@
                           <a:ea typeface="Malgun Gothic"/>
                           <a:cs typeface="Malgun Gothic"/>
                         </a:rPr>
-                        <a:t>힘에 강하게 다시 학습한 기반 추종기에 고유감각 이력의 잔차 적응기로 순응을 더함</a:t>
+                        <a:t>추종기 위 1 kHz 넘는 OSC(operational space control) + CBF(control barrier function) 제약, 필터를 아는 미세 조정</a:t>
                       </a:r>
                     </a:p>
                   </a:txBody>
@@ -45731,7 +45633,7 @@
                           <a:ea typeface="Malgun Gothic"/>
                           <a:cs typeface="Malgun Gothic"/>
                         </a:rPr>
-                        <a:t>60 N 이하 당김에서 기반 추종기 0.867(원래 SONIC 0.820). VLA 상자 과제 60 N 당김 46/50(28/50), 외란 없이 49/50(48/50)</a:t>
+                        <a:t>CoFiT: 필터만 붙인 경우 대비 제약 위반 시간 TWIST2 −91 %, SONIC −21 %(실물 TWIST2 −83 %)</a:t>
                       </a:r>
                     </a:p>
                   </a:txBody>
@@ -45757,13 +45659,134 @@
                           <a:ea typeface="Malgun Gothic"/>
                           <a:cs typeface="Malgun Gothic"/>
                         </a:rPr>
+                        <a:t>순응·안전</a:t>
+                      </a:r>
+                    </a:p>
+                  </a:txBody>
+                  <a:tcPr marL="63500" marR="63500" marT="12700" marB="12700">
+                    <a:solidFill>
+                      <a:srgbClr val="FFFDF8"/>
+                    </a:solidFill>
+                  </a:tcPr>
+                </a:tc>
+                <a:tc>
+                  <a:txBody>
+                    <a:bodyPr wrap="square"/>
+                    <a:lstStyle/>
+                    <a:p>
+                      <a:r>
+                        <a:rPr sz="800" b="0" i="0">
+                          <a:solidFill>
+                            <a:srgbClr val="16213A"/>
+                          </a:solidFill>
+                          <a:latin typeface="Arial"/>
+                          <a:ea typeface="Malgun Gothic"/>
+                          <a:cs typeface="Malgun Gothic"/>
+                        </a:rPr>
+                        <a:t>C-GMT(</a:t>
+                      </a:r>
+                      <a:r>
+                        <a:rPr sz="800" b="0" i="0">
+                          <a:solidFill>
+                            <a:srgbClr val="1D4ED8"/>
+                          </a:solidFill>
+                          <a:latin typeface="Arial"/>
+                          <a:ea typeface="Malgun Gothic"/>
+                          <a:cs typeface="Malgun Gothic"/>
+                          <a:hlinkClick r:id="rId10"/>
+                        </a:rPr>
+                        <a:t>arXiv:2610.22119</a:t>
+                      </a:r>
+                      <a:r>
+                        <a:rPr sz="800" b="0" i="0">
+                          <a:solidFill>
+                            <a:srgbClr val="16213A"/>
+                          </a:solidFill>
+                          <a:latin typeface="Arial"/>
+                          <a:ea typeface="Malgun Gothic"/>
+                          <a:cs typeface="Malgun Gothic"/>
+                        </a:rPr>
+                        <a:t>, MIT)</a:t>
+                      </a:r>
+                    </a:p>
+                  </a:txBody>
+                  <a:tcPr marL="63500" marR="63500" marT="12700" marB="12700">
+                    <a:solidFill>
+                      <a:srgbClr val="FFFDF8"/>
+                    </a:solidFill>
+                  </a:tcPr>
+                </a:tc>
+                <a:tc>
+                  <a:txBody>
+                    <a:bodyPr wrap="square"/>
+                    <a:lstStyle/>
+                    <a:p>
+                      <a:r>
+                        <a:rPr sz="800" b="0" i="0">
+                          <a:solidFill>
+                            <a:srgbClr val="16213A"/>
+                          </a:solidFill>
+                          <a:latin typeface="Arial"/>
+                          <a:ea typeface="Malgun Gothic"/>
+                          <a:cs typeface="Malgun Gothic"/>
+                        </a:rPr>
+                        <a:t>힘에 강하게 다시 학습한 기반 추종기에 고유감각 이력의 잔차 적응기로 순응을 더함</a:t>
+                      </a:r>
+                    </a:p>
+                  </a:txBody>
+                  <a:tcPr marL="63500" marR="63500" marT="12700" marB="12700">
+                    <a:solidFill>
+                      <a:srgbClr val="FFFDF8"/>
+                    </a:solidFill>
+                  </a:tcPr>
+                </a:tc>
+                <a:tc>
+                  <a:txBody>
+                    <a:bodyPr wrap="square"/>
+                    <a:lstStyle/>
+                    <a:p>
+                      <a:r>
+                        <a:rPr sz="800" b="0" i="0">
+                          <a:solidFill>
+                            <a:srgbClr val="16213A"/>
+                          </a:solidFill>
+                          <a:latin typeface="Arial"/>
+                          <a:ea typeface="Malgun Gothic"/>
+                          <a:cs typeface="Malgun Gothic"/>
+                        </a:rPr>
+                        <a:t>60 N 이하 당김에서 기반 추종기 0.867(원래 SONIC 0.820). VLA 상자 과제 60 N 당김 46/50(28/50), 외란 없이 49/50(48/50)</a:t>
+                      </a:r>
+                    </a:p>
+                  </a:txBody>
+                  <a:tcPr marL="63500" marR="63500" marT="12700" marB="12700">
+                    <a:solidFill>
+                      <a:srgbClr val="FFFDF8"/>
+                    </a:solidFill>
+                  </a:tcPr>
+                </a:tc>
+              </a:tr>
+              <a:tr h="317976">
+                <a:tc>
+                  <a:txBody>
+                    <a:bodyPr wrap="square"/>
+                    <a:lstStyle/>
+                    <a:p>
+                      <a:r>
+                        <a:rPr sz="800" b="0" i="0">
+                          <a:solidFill>
+                            <a:srgbClr val="16213A"/>
+                          </a:solidFill>
+                          <a:latin typeface="Arial"/>
+                          <a:ea typeface="Malgun Gothic"/>
+                          <a:cs typeface="Malgun Gothic"/>
+                        </a:rPr>
                         <a:t>실행 시점</a:t>
                       </a:r>
                     </a:p>
                   </a:txBody>
                   <a:tcPr marL="63500" marR="63500" marT="12700" marB="12700">
                     <a:solidFill>
-                      <a:srgbClr val="FFFDF8"/>
+                      <a:srgbClr val="F3F0E8"/>
                     </a:solidFill>
                   </a:tcPr>
                 </a:tc>
@@ -45791,7 +45814,7 @@
                           <a:latin typeface="Arial"/>
                           <a:ea typeface="Malgun Gothic"/>
                           <a:cs typeface="Malgun Gothic"/>
-                          <a:hlinkClick r:id="rId9"/>
+                          <a:hlinkClick r:id="rId11"/>
                         </a:rPr>
                         <a:t>arXiv:2610.14896</a:t>
                       </a:r>
@@ -45810,7 +45833,7 @@
                   </a:txBody>
                   <a:tcPr marL="63500" marR="63500" marT="12700" marB="12700">
                     <a:solidFill>
-                      <a:srgbClr val="FFFDF8"/>
+                      <a:srgbClr val="F3F0E8"/>
                     </a:solidFill>
                   </a:tcPr>
                 </a:tc>
@@ -45834,7 +45857,7 @@
                   </a:txBody>
                   <a:tcPr marL="63500" marR="63500" marT="12700" marB="12700">
                     <a:solidFill>
-                      <a:srgbClr val="FFFDF8"/>
+                      <a:srgbClr val="F3F0E8"/>
                     </a:solidFill>
                   </a:tcPr>
                 </a:tc>
@@ -45858,7 +45881,7 @@
                   </a:txBody>
                   <a:tcPr marL="63500" marR="63500" marT="12700" marB="12700">
                     <a:solidFill>
-                      <a:srgbClr val="FFFDF8"/>
+                      <a:srgbClr val="F3F0E8"/>
                     </a:solidFill>
                   </a:tcPr>
                 </a:tc>
@@ -45875,7 +45898,7 @@
         </p:nvSpPr>
         <p:spPr>
           <a:xfrm>
-            <a:off x="609600" y="3573562"/>
+            <a:off x="609600" y="4122142"/>
             <a:ext cx="10972800" cy="1298972"/>
           </a:xfrm>
           <a:prstGeom prst="rect">
@@ -45920,7 +45943,7 @@
                 <a:latin typeface="Arial"/>
                 <a:ea typeface="Malgun Gothic"/>
                 <a:cs typeface="Malgun Gothic"/>
-                <a:hlinkClick r:id="rId10"/>
+                <a:hlinkClick r:id="rId12"/>
               </a:rPr>
               <a:t>arXiv:2607.04837</a:t>
             </a:r>

</xml_diff>